<commit_message>
Improve seasonal and price fallback metrics
This change avoids zero or NaN outputs when exact seasonal climate data is missing by falling back to nearby regional records and then weather data. It also adds a regional/crop fallback for price estimates when a survey row is absent, using a median-based estimate to keep the dashboard informative. The presentation deck was updated to reflect the refreshed app outputs.

Co-Authored-By: Oli Bakala <olibekele50@gmail.com>
Co-Authored-By: ERMIYAS ZEWDU ASSEFA <168017946+ERMIYASZEWDU@users.noreply.github.com>
Co-Authored-By: Bereket G/alif <151466759+bereket5185@users.noreply.github.com>
</commit_message>
<xml_diff>
--- a/presentation/team_11_presentation.pptx
+++ b/presentation/team_11_presentation.pptx
@@ -5,15 +5,15 @@
     <p:sldMasterId id="2147483648" r:id="rId1"/>
   </p:sldMasterIdLst>
   <p:sldIdLst>
-    <p:sldId id="256" r:id="rId7"/>
-    <p:sldId id="257" r:id="rId8"/>
-    <p:sldId id="258" r:id="rId9"/>
-    <p:sldId id="259" r:id="rId10"/>
-    <p:sldId id="260" r:id="rId11"/>
-    <p:sldId id="261" r:id="rId12"/>
-    <p:sldId id="262" r:id="rId13"/>
+    <p:sldId id="256" r:id="rId2"/>
+    <p:sldId id="257" r:id="rId3"/>
+    <p:sldId id="258" r:id="rId4"/>
+    <p:sldId id="259" r:id="rId5"/>
+    <p:sldId id="260" r:id="rId6"/>
+    <p:sldId id="261" r:id="rId7"/>
+    <p:sldId id="262" r:id="rId8"/>
   </p:sldIdLst>
-  <p:sldSz cx="12191695" cy="6858000" type="screen4x3"/>
+  <p:sldSz cx="12192000" cy="6858000"/>
   <p:notesSz cx="6858000" cy="9144000"/>
   <p:defaultTextStyle>
     <a:defPPr>
@@ -294,7 +294,7 @@
           <a:p>
             <a:fld id="{5BCAD085-E8A6-8845-BD4E-CB4CCA059FC4}" type="datetimeFigureOut">
               <a:rPr lang="en-US" smtClean="0"/>
-              <a:t>1/27/13</a:t>
+              <a:t>10/6/2026</a:t>
             </a:fld>
             <a:endParaRPr lang="en-US"/>
           </a:p>
@@ -464,7 +464,7 @@
           <a:p>
             <a:fld id="{5BCAD085-E8A6-8845-BD4E-CB4CCA059FC4}" type="datetimeFigureOut">
               <a:rPr lang="en-US" smtClean="0"/>
-              <a:t>1/27/13</a:t>
+              <a:t>10/6/2026</a:t>
             </a:fld>
             <a:endParaRPr lang="en-US"/>
           </a:p>
@@ -644,7 +644,7 @@
           <a:p>
             <a:fld id="{5BCAD085-E8A6-8845-BD4E-CB4CCA059FC4}" type="datetimeFigureOut">
               <a:rPr lang="en-US" smtClean="0"/>
-              <a:t>1/27/13</a:t>
+              <a:t>10/6/2026</a:t>
             </a:fld>
             <a:endParaRPr lang="en-US"/>
           </a:p>
@@ -814,7 +814,7 @@
           <a:p>
             <a:fld id="{5BCAD085-E8A6-8845-BD4E-CB4CCA059FC4}" type="datetimeFigureOut">
               <a:rPr lang="en-US" smtClean="0"/>
-              <a:t>1/27/13</a:t>
+              <a:t>10/6/2026</a:t>
             </a:fld>
             <a:endParaRPr lang="en-US"/>
           </a:p>
@@ -1060,7 +1060,7 @@
           <a:p>
             <a:fld id="{5BCAD085-E8A6-8845-BD4E-CB4CCA059FC4}" type="datetimeFigureOut">
               <a:rPr lang="en-US" smtClean="0"/>
-              <a:t>1/27/13</a:t>
+              <a:t>10/6/2026</a:t>
             </a:fld>
             <a:endParaRPr lang="en-US"/>
           </a:p>
@@ -1348,7 +1348,7 @@
           <a:p>
             <a:fld id="{5BCAD085-E8A6-8845-BD4E-CB4CCA059FC4}" type="datetimeFigureOut">
               <a:rPr lang="en-US" smtClean="0"/>
-              <a:t>1/27/13</a:t>
+              <a:t>10/6/2026</a:t>
             </a:fld>
             <a:endParaRPr lang="en-US"/>
           </a:p>
@@ -1770,7 +1770,7 @@
           <a:p>
             <a:fld id="{5BCAD085-E8A6-8845-BD4E-CB4CCA059FC4}" type="datetimeFigureOut">
               <a:rPr lang="en-US" smtClean="0"/>
-              <a:t>1/27/13</a:t>
+              <a:t>10/6/2026</a:t>
             </a:fld>
             <a:endParaRPr lang="en-US"/>
           </a:p>
@@ -1888,7 +1888,7 @@
           <a:p>
             <a:fld id="{5BCAD085-E8A6-8845-BD4E-CB4CCA059FC4}" type="datetimeFigureOut">
               <a:rPr lang="en-US" smtClean="0"/>
-              <a:t>1/27/13</a:t>
+              <a:t>10/6/2026</a:t>
             </a:fld>
             <a:endParaRPr lang="en-US"/>
           </a:p>
@@ -1983,7 +1983,7 @@
           <a:p>
             <a:fld id="{5BCAD085-E8A6-8845-BD4E-CB4CCA059FC4}" type="datetimeFigureOut">
               <a:rPr lang="en-US" smtClean="0"/>
-              <a:t>1/27/13</a:t>
+              <a:t>10/6/2026</a:t>
             </a:fld>
             <a:endParaRPr lang="en-US"/>
           </a:p>
@@ -2260,7 +2260,7 @@
           <a:p>
             <a:fld id="{5BCAD085-E8A6-8845-BD4E-CB4CCA059FC4}" type="datetimeFigureOut">
               <a:rPr lang="en-US" smtClean="0"/>
-              <a:t>1/27/13</a:t>
+              <a:t>10/6/2026</a:t>
             </a:fld>
             <a:endParaRPr lang="en-US"/>
           </a:p>
@@ -2513,7 +2513,7 @@
           <a:p>
             <a:fld id="{5BCAD085-E8A6-8845-BD4E-CB4CCA059FC4}" type="datetimeFigureOut">
               <a:rPr lang="en-US" smtClean="0"/>
-              <a:t>1/27/13</a:t>
+              <a:t>10/6/2026</a:t>
             </a:fld>
             <a:endParaRPr lang="en-US"/>
           </a:p>
@@ -2726,7 +2726,7 @@
           <a:p>
             <a:fld id="{5BCAD085-E8A6-8845-BD4E-CB4CCA059FC4}" type="datetimeFigureOut">
               <a:rPr lang="en-US" smtClean="0"/>
-              <a:t>1/27/13</a:t>
+              <a:t>10/6/2026</a:t>
             </a:fld>
             <a:endParaRPr lang="en-US"/>
           </a:p>
@@ -3085,7 +3085,7 @@
 </file>
 
 <file path=ppt/slides/slide1.xml><?xml version="1.0" encoding="utf-8"?>
-<p:sld xmlns:a="http://schemas.openxmlformats.org/drawingml/2006/main" xmlns:p="http://schemas.openxmlformats.org/presentationml/2006/main" xmlns:r="http://schemas.openxmlformats.org/officeDocument/2006/relationships">
+<p:sld xmlns:a="http://schemas.openxmlformats.org/drawingml/2006/main" xmlns:r="http://schemas.openxmlformats.org/officeDocument/2006/relationships" xmlns:p="http://schemas.openxmlformats.org/presentationml/2006/main">
   <p:cSld>
     <p:bg>
       <p:bgPr>
@@ -3101,7 +3101,14 @@
         <p:cNvGrpSpPr/>
         <p:nvPr/>
       </p:nvGrpSpPr>
-      <p:grpSpPr/>
+      <p:grpSpPr>
+        <a:xfrm>
+          <a:off x="0" y="0"/>
+          <a:ext cx="0" cy="0"/>
+          <a:chOff x="0" y="0"/>
+          <a:chExt cx="0" cy="0"/>
+        </a:xfrm>
+      </p:grpSpPr>
       <p:sp>
         <p:nvSpPr>
           <p:cNvPr id="2" name="Rectangle 1"/>
@@ -3142,6 +3149,7 @@
           <a:lstStyle/>
           <a:p>
             <a:pPr algn="ctr"/>
+            <a:endParaRPr/>
           </a:p>
         </p:txBody>
       </p:sp>
@@ -3185,6 +3193,7 @@
           <a:lstStyle/>
           <a:p>
             <a:pPr algn="ctr"/>
+            <a:endParaRPr/>
           </a:p>
         </p:txBody>
       </p:sp>
@@ -3212,7 +3221,7 @@
           <a:p>
             <a:pPr algn="ctr"/>
             <a:r>
-              <a:rPr b="1" sz="2800">
+              <a:rPr sz="2800" b="1">
                 <a:solidFill>
                   <a:srgbClr val="FFFFFF"/>
                 </a:solidFill>
@@ -3346,6 +3355,7 @@
           <a:lstStyle/>
           <a:p>
             <a:pPr algn="ctr"/>
+            <a:endParaRPr/>
           </a:p>
         </p:txBody>
       </p:sp>
@@ -3373,7 +3383,7 @@
           <a:p>
             <a:pPr algn="ctr"/>
             <a:r>
-              <a:rPr b="1" sz="1200">
+              <a:rPr sz="1200" b="1">
                 <a:solidFill>
                   <a:srgbClr val="2E7D5C"/>
                 </a:solidFill>
@@ -3425,6 +3435,7 @@
           <a:lstStyle/>
           <a:p>
             <a:pPr algn="ctr"/>
+            <a:endParaRPr/>
           </a:p>
         </p:txBody>
       </p:sp>
@@ -3452,7 +3463,7 @@
           <a:p>
             <a:pPr algn="ctr"/>
             <a:r>
-              <a:rPr b="1" sz="1200">
+              <a:rPr sz="1200" b="1">
                 <a:solidFill>
                   <a:srgbClr val="2E7D5C"/>
                 </a:solidFill>
@@ -3504,6 +3515,7 @@
           <a:lstStyle/>
           <a:p>
             <a:pPr algn="ctr"/>
+            <a:endParaRPr/>
           </a:p>
         </p:txBody>
       </p:sp>
@@ -3531,7 +3543,7 @@
           <a:p>
             <a:pPr algn="ctr"/>
             <a:r>
-              <a:rPr b="1" sz="1200">
+              <a:rPr sz="1200" b="1">
                 <a:solidFill>
                   <a:srgbClr val="2E7D5C"/>
                 </a:solidFill>
@@ -3583,6 +3595,7 @@
           <a:lstStyle/>
           <a:p>
             <a:pPr algn="ctr"/>
+            <a:endParaRPr/>
           </a:p>
         </p:txBody>
       </p:sp>
@@ -3610,7 +3623,7 @@
           <a:p>
             <a:pPr algn="l"/>
             <a:r>
-              <a:rPr b="1" sz="1400">
+              <a:rPr sz="1400" b="1">
                 <a:solidFill>
                   <a:srgbClr val="0C2034"/>
                 </a:solidFill>
@@ -3662,6 +3675,7 @@
           <a:lstStyle/>
           <a:p>
             <a:pPr algn="ctr"/>
+            <a:endParaRPr/>
           </a:p>
         </p:txBody>
       </p:sp>
@@ -3688,7 +3702,7 @@
           <a:lstStyle/>
           <a:p>
             <a:r>
-              <a:rPr b="1" sz="1000">
+              <a:rPr sz="1000" b="1">
                 <a:solidFill>
                   <a:srgbClr val="0C2034"/>
                 </a:solidFill>
@@ -3721,7 +3735,7 @@
           <a:lstStyle/>
           <a:p>
             <a:r>
-              <a:rPr b="1" sz="1600">
+              <a:rPr sz="1600" b="1">
                 <a:solidFill>
                   <a:srgbClr val="2E7D5C"/>
                 </a:solidFill>
@@ -3773,6 +3787,7 @@
           <a:lstStyle/>
           <a:p>
             <a:pPr algn="ctr"/>
+            <a:endParaRPr/>
           </a:p>
         </p:txBody>
       </p:sp>
@@ -3799,7 +3814,7 @@
           <a:lstStyle/>
           <a:p>
             <a:r>
-              <a:rPr b="1" sz="1000">
+              <a:rPr sz="1000" b="1">
                 <a:solidFill>
                   <a:srgbClr val="0C2034"/>
                 </a:solidFill>
@@ -3832,7 +3847,7 @@
           <a:lstStyle/>
           <a:p>
             <a:r>
-              <a:rPr b="1" sz="1600">
+              <a:rPr sz="1600" b="1">
                 <a:solidFill>
                   <a:srgbClr val="2E7D5C"/>
                 </a:solidFill>
@@ -3884,6 +3899,7 @@
           <a:lstStyle/>
           <a:p>
             <a:pPr algn="ctr"/>
+            <a:endParaRPr/>
           </a:p>
         </p:txBody>
       </p:sp>
@@ -3910,7 +3926,7 @@
           <a:lstStyle/>
           <a:p>
             <a:r>
-              <a:rPr b="1" sz="1000">
+              <a:rPr sz="1000" b="1">
                 <a:solidFill>
                   <a:srgbClr val="0C2034"/>
                 </a:solidFill>
@@ -3943,7 +3959,7 @@
           <a:lstStyle/>
           <a:p>
             <a:r>
-              <a:rPr b="1" sz="1600">
+              <a:rPr sz="1600" b="1">
                 <a:solidFill>
                   <a:srgbClr val="2E7D5C"/>
                 </a:solidFill>
@@ -3962,7 +3978,7 @@
 </file>
 
 <file path=ppt/slides/slide2.xml><?xml version="1.0" encoding="utf-8"?>
-<p:sld xmlns:a="http://schemas.openxmlformats.org/drawingml/2006/main" xmlns:p="http://schemas.openxmlformats.org/presentationml/2006/main" xmlns:r="http://schemas.openxmlformats.org/officeDocument/2006/relationships">
+<p:sld xmlns:a="http://schemas.openxmlformats.org/drawingml/2006/main" xmlns:r="http://schemas.openxmlformats.org/officeDocument/2006/relationships" xmlns:p="http://schemas.openxmlformats.org/presentationml/2006/main">
   <p:cSld>
     <p:bg>
       <p:bgPr>
@@ -3978,7 +3994,14 @@
         <p:cNvGrpSpPr/>
         <p:nvPr/>
       </p:nvGrpSpPr>
-      <p:grpSpPr/>
+      <p:grpSpPr>
+        <a:xfrm>
+          <a:off x="0" y="0"/>
+          <a:ext cx="0" cy="0"/>
+          <a:chOff x="0" y="0"/>
+          <a:chExt cx="0" cy="0"/>
+        </a:xfrm>
+      </p:grpSpPr>
       <p:sp>
         <p:nvSpPr>
           <p:cNvPr id="2" name="TextBox 1"/>
@@ -3988,7 +4011,7 @@
         <p:spPr>
           <a:xfrm>
             <a:off x="594360" y="411480"/>
-            <a:ext cx="8686800" cy="731520"/>
+            <a:ext cx="8686800" cy="492443"/>
           </a:xfrm>
           <a:prstGeom prst="rect">
             <a:avLst/>
@@ -4003,10 +4026,7 @@
           <a:p>
             <a:pPr algn="l"/>
             <a:r>
-              <a:rPr sz="2600" b="1">
-                <a:solidFill>
-                  <a:srgbClr val="FFFFFF"/>
-                </a:solidFill>
+              <a:rPr sz="2600" b="1" dirty="0">
                 <a:latin typeface="Aptos"/>
               </a:rPr>
               <a:t>Project objective</a:t>
@@ -4023,7 +4043,7 @@
         <p:spPr>
           <a:xfrm>
             <a:off x="621792" y="987552"/>
-            <a:ext cx="7772400" cy="457200"/>
+            <a:ext cx="4172937" cy="261610"/>
           </a:xfrm>
           <a:prstGeom prst="rect">
             <a:avLst/>
@@ -4038,10 +4058,7 @@
           <a:p>
             <a:pPr algn="l"/>
             <a:r>
-              <a:rPr sz="1100">
-                <a:solidFill>
-                  <a:srgbClr val="FFFFFF"/>
-                </a:solidFill>
+              <a:rPr sz="1100" dirty="0">
                 <a:latin typeface="Aptos"/>
               </a:rPr>
               <a:t>Build a reliable crop yield forecast under competition constraints</a:t>
@@ -4091,6 +4108,7 @@
           <a:lstStyle/>
           <a:p>
             <a:pPr algn="ctr"/>
+            <a:endParaRPr/>
           </a:p>
         </p:txBody>
       </p:sp>
@@ -4118,7 +4136,7 @@
           <a:p>
             <a:pPr algn="l"/>
             <a:r>
-              <a:rPr b="1" sz="1500">
+              <a:rPr sz="1500" b="1">
                 <a:solidFill>
                   <a:srgbClr val="2E7D5C"/>
                 </a:solidFill>
@@ -4258,6 +4276,7 @@
           <a:lstStyle/>
           <a:p>
             <a:pPr algn="ctr"/>
+            <a:endParaRPr/>
           </a:p>
         </p:txBody>
       </p:sp>
@@ -4285,7 +4304,7 @@
           <a:p>
             <a:pPr algn="l"/>
             <a:r>
-              <a:rPr b="1" sz="1500">
+              <a:rPr sz="1500" b="1">
                 <a:solidFill>
                   <a:srgbClr val="215E98"/>
                 </a:solidFill>
@@ -4425,6 +4444,7 @@
           <a:lstStyle/>
           <a:p>
             <a:pPr algn="ctr"/>
+            <a:endParaRPr/>
           </a:p>
         </p:txBody>
       </p:sp>
@@ -4452,7 +4472,7 @@
           <a:p>
             <a:pPr algn="l"/>
             <a:r>
-              <a:rPr b="1" sz="1500">
+              <a:rPr sz="1500" b="1">
                 <a:solidFill>
                   <a:srgbClr val="F3A334"/>
                 </a:solidFill>
@@ -4559,7 +4579,7 @@
 </file>
 
 <file path=ppt/slides/slide3.xml><?xml version="1.0" encoding="utf-8"?>
-<p:sld xmlns:a="http://schemas.openxmlformats.org/drawingml/2006/main" xmlns:p="http://schemas.openxmlformats.org/presentationml/2006/main" xmlns:r="http://schemas.openxmlformats.org/officeDocument/2006/relationships">
+<p:sld xmlns:a="http://schemas.openxmlformats.org/drawingml/2006/main" xmlns:r="http://schemas.openxmlformats.org/officeDocument/2006/relationships" xmlns:p="http://schemas.openxmlformats.org/presentationml/2006/main">
   <p:cSld>
     <p:bg>
       <p:bgPr>
@@ -4575,7 +4595,14 @@
         <p:cNvGrpSpPr/>
         <p:nvPr/>
       </p:nvGrpSpPr>
-      <p:grpSpPr/>
+      <p:grpSpPr>
+        <a:xfrm>
+          <a:off x="0" y="0"/>
+          <a:ext cx="0" cy="0"/>
+          <a:chOff x="0" y="0"/>
+          <a:chExt cx="0" cy="0"/>
+        </a:xfrm>
+      </p:grpSpPr>
       <p:sp>
         <p:nvSpPr>
           <p:cNvPr id="2" name="TextBox 1"/>
@@ -4585,7 +4612,7 @@
         <p:spPr>
           <a:xfrm>
             <a:off x="594360" y="411480"/>
-            <a:ext cx="8686800" cy="731520"/>
+            <a:ext cx="8686800" cy="492443"/>
           </a:xfrm>
           <a:prstGeom prst="rect">
             <a:avLst/>
@@ -4600,10 +4627,7 @@
           <a:p>
             <a:pPr algn="l"/>
             <a:r>
-              <a:rPr sz="2600" b="1">
-                <a:solidFill>
-                  <a:srgbClr val="FFFFFF"/>
-                </a:solidFill>
+              <a:rPr sz="2600" b="1" dirty="0">
                 <a:latin typeface="Aptos"/>
               </a:rPr>
               <a:t>Data and cleaning pipeline</a:t>
@@ -4620,7 +4644,7 @@
         <p:spPr>
           <a:xfrm>
             <a:off x="621792" y="987552"/>
-            <a:ext cx="7772400" cy="457200"/>
+            <a:ext cx="3903633" cy="261610"/>
           </a:xfrm>
           <a:prstGeom prst="rect">
             <a:avLst/>
@@ -4635,10 +4659,7 @@
           <a:p>
             <a:pPr algn="l"/>
             <a:r>
-              <a:rPr sz="1100">
-                <a:solidFill>
-                  <a:srgbClr val="FFFFFF"/>
-                </a:solidFill>
+              <a:rPr sz="1100" dirty="0">
                 <a:latin typeface="Aptos"/>
               </a:rPr>
               <a:t>Traceable preprocessing from raw files to model-ready data</a:t>
@@ -4688,6 +4709,7 @@
           <a:lstStyle/>
           <a:p>
             <a:pPr algn="ctr"/>
+            <a:endParaRPr/>
           </a:p>
         </p:txBody>
       </p:sp>
@@ -4715,7 +4737,7 @@
           <a:p>
             <a:pPr algn="l"/>
             <a:r>
-              <a:rPr b="1" sz="1500">
+              <a:rPr sz="1500" b="1">
                 <a:solidFill>
                   <a:srgbClr val="2E7D5C"/>
                 </a:solidFill>
@@ -4855,6 +4877,7 @@
           <a:lstStyle/>
           <a:p>
             <a:pPr algn="ctr"/>
+            <a:endParaRPr/>
           </a:p>
         </p:txBody>
       </p:sp>
@@ -4882,7 +4905,7 @@
           <a:p>
             <a:pPr algn="l"/>
             <a:r>
-              <a:rPr b="1" sz="1500">
+              <a:rPr sz="1500" b="1">
                 <a:solidFill>
                   <a:srgbClr val="215E98"/>
                 </a:solidFill>
@@ -5022,6 +5045,7 @@
           <a:lstStyle/>
           <a:p>
             <a:pPr algn="ctr"/>
+            <a:endParaRPr/>
           </a:p>
         </p:txBody>
       </p:sp>
@@ -5049,7 +5073,7 @@
           <a:p>
             <a:pPr algn="l"/>
             <a:r>
-              <a:rPr b="1" sz="1500">
+              <a:rPr sz="1500" b="1">
                 <a:solidFill>
                   <a:srgbClr val="F3A334"/>
                 </a:solidFill>
@@ -5156,7 +5180,7 @@
 </file>
 
 <file path=ppt/slides/slide4.xml><?xml version="1.0" encoding="utf-8"?>
-<p:sld xmlns:a="http://schemas.openxmlformats.org/drawingml/2006/main" xmlns:p="http://schemas.openxmlformats.org/presentationml/2006/main" xmlns:r="http://schemas.openxmlformats.org/officeDocument/2006/relationships">
+<p:sld xmlns:a="http://schemas.openxmlformats.org/drawingml/2006/main" xmlns:r="http://schemas.openxmlformats.org/officeDocument/2006/relationships" xmlns:p="http://schemas.openxmlformats.org/presentationml/2006/main">
   <p:cSld>
     <p:bg>
       <p:bgPr>
@@ -5172,7 +5196,14 @@
         <p:cNvGrpSpPr/>
         <p:nvPr/>
       </p:nvGrpSpPr>
-      <p:grpSpPr/>
+      <p:grpSpPr>
+        <a:xfrm>
+          <a:off x="0" y="0"/>
+          <a:ext cx="0" cy="0"/>
+          <a:chOff x="0" y="0"/>
+          <a:chExt cx="0" cy="0"/>
+        </a:xfrm>
+      </p:grpSpPr>
       <p:sp>
         <p:nvSpPr>
           <p:cNvPr id="2" name="TextBox 1"/>
@@ -5252,7 +5283,7 @@
         <p:spPr>
           <a:xfrm>
             <a:off x="685800" y="1645920"/>
-            <a:ext cx="2468880" cy="2286000"/>
+            <a:ext cx="2598576" cy="2286000"/>
           </a:xfrm>
           <a:prstGeom prst="roundRect">
             <a:avLst/>
@@ -5285,6 +5316,7 @@
           <a:lstStyle/>
           <a:p>
             <a:pPr algn="ctr"/>
+            <a:endParaRPr/>
           </a:p>
         </p:txBody>
       </p:sp>
@@ -5297,7 +5329,7 @@
         <p:spPr>
           <a:xfrm>
             <a:off x="868680" y="1755648"/>
-            <a:ext cx="2103120" cy="274320"/>
+            <a:ext cx="2492734" cy="323165"/>
           </a:xfrm>
           <a:prstGeom prst="rect">
             <a:avLst/>
@@ -5312,10 +5344,7 @@
           <a:p>
             <a:pPr algn="l"/>
             <a:r>
-              <a:rPr b="1" sz="1500">
-                <a:solidFill>
-                  <a:srgbClr val="D9EFE4"/>
-                </a:solidFill>
+              <a:rPr sz="1500" b="1" dirty="0">
                 <a:latin typeface="Aptos"/>
               </a:rPr>
               <a:t>Weather-derived features</a:t>
@@ -5351,7 +5380,7 @@
               </a:spcAft>
             </a:pPr>
             <a:r>
-              <a:rPr sz="1100">
+              <a:rPr sz="1100" dirty="0">
                 <a:solidFill>
                   <a:srgbClr val="212121"/>
                 </a:solidFill>
@@ -5367,7 +5396,7 @@
               </a:spcAft>
             </a:pPr>
             <a:r>
-              <a:rPr sz="1100">
+              <a:rPr sz="1100" dirty="0">
                 <a:solidFill>
                   <a:srgbClr val="212121"/>
                 </a:solidFill>
@@ -5383,7 +5412,7 @@
               </a:spcAft>
             </a:pPr>
             <a:r>
-              <a:rPr sz="1100">
+              <a:rPr sz="1100" dirty="0">
                 <a:solidFill>
                   <a:srgbClr val="212121"/>
                 </a:solidFill>
@@ -5399,7 +5428,7 @@
               </a:spcAft>
             </a:pPr>
             <a:r>
-              <a:rPr sz="1100">
+              <a:rPr sz="1100" dirty="0">
                 <a:solidFill>
                   <a:srgbClr val="212121"/>
                 </a:solidFill>
@@ -5452,6 +5481,7 @@
           <a:lstStyle/>
           <a:p>
             <a:pPr algn="ctr"/>
+            <a:endParaRPr/>
           </a:p>
         </p:txBody>
       </p:sp>
@@ -5464,7 +5494,7 @@
         <p:spPr>
           <a:xfrm>
             <a:off x="3611880" y="1755648"/>
-            <a:ext cx="2103120" cy="274320"/>
+            <a:ext cx="2002471" cy="323165"/>
           </a:xfrm>
           <a:prstGeom prst="rect">
             <a:avLst/>
@@ -5479,10 +5509,7 @@
           <a:p>
             <a:pPr algn="l"/>
             <a:r>
-              <a:rPr b="1" sz="1500">
-                <a:solidFill>
-                  <a:srgbClr val="D9EFE4"/>
-                </a:solidFill>
+              <a:rPr sz="1500" b="1" dirty="0">
                 <a:latin typeface="Aptos"/>
               </a:rPr>
               <a:t>Agronomic features</a:t>
@@ -5518,7 +5545,7 @@
               </a:spcAft>
             </a:pPr>
             <a:r>
-              <a:rPr sz="1100">
+              <a:rPr sz="1100" dirty="0">
                 <a:solidFill>
                   <a:srgbClr val="212121"/>
                 </a:solidFill>
@@ -5534,7 +5561,7 @@
               </a:spcAft>
             </a:pPr>
             <a:r>
-              <a:rPr sz="1100">
+              <a:rPr sz="1100" dirty="0">
                 <a:solidFill>
                   <a:srgbClr val="212121"/>
                 </a:solidFill>
@@ -5550,7 +5577,7 @@
               </a:spcAft>
             </a:pPr>
             <a:r>
-              <a:rPr sz="1100">
+              <a:rPr sz="1100" dirty="0">
                 <a:solidFill>
                   <a:srgbClr val="212121"/>
                 </a:solidFill>
@@ -5566,7 +5593,7 @@
               </a:spcAft>
             </a:pPr>
             <a:r>
-              <a:rPr sz="1100">
+              <a:rPr sz="1100" dirty="0">
                 <a:solidFill>
                   <a:srgbClr val="212121"/>
                 </a:solidFill>
@@ -5619,6 +5646,7 @@
           <a:lstStyle/>
           <a:p>
             <a:pPr algn="ctr"/>
+            <a:endParaRPr/>
           </a:p>
         </p:txBody>
       </p:sp>
@@ -5631,7 +5659,7 @@
         <p:spPr>
           <a:xfrm>
             <a:off x="6355080" y="1755648"/>
-            <a:ext cx="2103120" cy="274320"/>
+            <a:ext cx="2008883" cy="323165"/>
           </a:xfrm>
           <a:prstGeom prst="rect">
             <a:avLst/>
@@ -5646,10 +5674,7 @@
           <a:p>
             <a:pPr algn="l"/>
             <a:r>
-              <a:rPr b="1" sz="1500">
-                <a:solidFill>
-                  <a:srgbClr val="D9EFE4"/>
-                </a:solidFill>
+              <a:rPr sz="1500" b="1" dirty="0">
                 <a:latin typeface="Aptos"/>
               </a:rPr>
               <a:t>Modeling guardrails</a:t>
@@ -5685,7 +5710,7 @@
               </a:spcAft>
             </a:pPr>
             <a:r>
-              <a:rPr sz="1100">
+              <a:rPr sz="1100" dirty="0">
                 <a:solidFill>
                   <a:srgbClr val="212121"/>
                 </a:solidFill>
@@ -5701,7 +5726,7 @@
               </a:spcAft>
             </a:pPr>
             <a:r>
-              <a:rPr sz="1100">
+              <a:rPr sz="1100" dirty="0">
                 <a:solidFill>
                   <a:srgbClr val="212121"/>
                 </a:solidFill>
@@ -5717,7 +5742,7 @@
               </a:spcAft>
             </a:pPr>
             <a:r>
-              <a:rPr sz="1100">
+              <a:rPr sz="1100" dirty="0">
                 <a:solidFill>
                   <a:srgbClr val="212121"/>
                 </a:solidFill>
@@ -5733,7 +5758,7 @@
               </a:spcAft>
             </a:pPr>
             <a:r>
-              <a:rPr sz="1100">
+              <a:rPr sz="1100" dirty="0">
                 <a:solidFill>
                   <a:srgbClr val="212121"/>
                 </a:solidFill>
@@ -5786,6 +5811,7 @@
           <a:lstStyle/>
           <a:p>
             <a:pPr algn="ctr"/>
+            <a:endParaRPr/>
           </a:p>
         </p:txBody>
       </p:sp>
@@ -5813,7 +5839,7 @@
           <a:p>
             <a:pPr algn="l"/>
             <a:r>
-              <a:rPr b="1" sz="1500">
+              <a:rPr sz="1500" b="1">
                 <a:solidFill>
                   <a:srgbClr val="F3A334"/>
                 </a:solidFill>
@@ -5920,7 +5946,7 @@
 </file>
 
 <file path=ppt/slides/slide5.xml><?xml version="1.0" encoding="utf-8"?>
-<p:sld xmlns:a="http://schemas.openxmlformats.org/drawingml/2006/main" xmlns:p="http://schemas.openxmlformats.org/presentationml/2006/main" xmlns:r="http://schemas.openxmlformats.org/officeDocument/2006/relationships">
+<p:sld xmlns:a="http://schemas.openxmlformats.org/drawingml/2006/main" xmlns:r="http://schemas.openxmlformats.org/officeDocument/2006/relationships" xmlns:p="http://schemas.openxmlformats.org/presentationml/2006/main">
   <p:cSld>
     <p:bg>
       <p:bgPr>
@@ -5936,7 +5962,14 @@
         <p:cNvGrpSpPr/>
         <p:nvPr/>
       </p:nvGrpSpPr>
-      <p:grpSpPr/>
+      <p:grpSpPr>
+        <a:xfrm>
+          <a:off x="0" y="0"/>
+          <a:ext cx="0" cy="0"/>
+          <a:chOff x="0" y="0"/>
+          <a:chExt cx="0" cy="0"/>
+        </a:xfrm>
+      </p:grpSpPr>
       <p:sp>
         <p:nvSpPr>
           <p:cNvPr id="2" name="TextBox 1"/>
@@ -5946,7 +5979,7 @@
         <p:spPr>
           <a:xfrm>
             <a:off x="594360" y="411480"/>
-            <a:ext cx="8686800" cy="731520"/>
+            <a:ext cx="8686800" cy="492443"/>
           </a:xfrm>
           <a:prstGeom prst="rect">
             <a:avLst/>
@@ -5961,10 +5994,7 @@
           <a:p>
             <a:pPr algn="l"/>
             <a:r>
-              <a:rPr sz="2600" b="1">
-                <a:solidFill>
-                  <a:srgbClr val="FFFFFF"/>
-                </a:solidFill>
+              <a:rPr sz="2600" b="1" dirty="0">
                 <a:latin typeface="Aptos"/>
               </a:rPr>
               <a:t>Modeling and validation</a:t>
@@ -5981,7 +6011,7 @@
         <p:spPr>
           <a:xfrm>
             <a:off x="621792" y="987552"/>
-            <a:ext cx="7772400" cy="457200"/>
+            <a:ext cx="4639412" cy="261610"/>
           </a:xfrm>
           <a:prstGeom prst="rect">
             <a:avLst/>
@@ -5996,10 +6026,7 @@
           <a:p>
             <a:pPr algn="l"/>
             <a:r>
-              <a:rPr sz="1100">
-                <a:solidFill>
-                  <a:srgbClr val="FFFFFF"/>
-                </a:solidFill>
+              <a:rPr sz="1100" dirty="0">
                 <a:latin typeface="Aptos"/>
               </a:rPr>
               <a:t>Comparing baseline and predictive models on a held-out validation split</a:t>
@@ -6049,6 +6076,7 @@
           <a:lstStyle/>
           <a:p>
             <a:pPr algn="ctr"/>
+            <a:endParaRPr/>
           </a:p>
         </p:txBody>
       </p:sp>
@@ -6094,6 +6122,7 @@
           <a:lstStyle/>
           <a:p>
             <a:pPr algn="ctr"/>
+            <a:endParaRPr/>
           </a:p>
         </p:txBody>
       </p:sp>
@@ -6121,7 +6150,7 @@
           <a:p>
             <a:pPr algn="ctr"/>
             <a:r>
-              <a:rPr b="1" sz="1200">
+              <a:rPr sz="1200" b="1">
                 <a:solidFill>
                   <a:srgbClr val="FFFFFF"/>
                 </a:solidFill>
@@ -6173,6 +6202,7 @@
           <a:lstStyle/>
           <a:p>
             <a:pPr algn="ctr"/>
+            <a:endParaRPr/>
           </a:p>
         </p:txBody>
       </p:sp>
@@ -6200,7 +6230,7 @@
           <a:p>
             <a:pPr algn="ctr"/>
             <a:r>
-              <a:rPr b="1" sz="1200">
+              <a:rPr sz="1200" b="1">
                 <a:solidFill>
                   <a:srgbClr val="FFFFFF"/>
                 </a:solidFill>
@@ -6252,6 +6282,7 @@
           <a:lstStyle/>
           <a:p>
             <a:pPr algn="ctr"/>
+            <a:endParaRPr/>
           </a:p>
         </p:txBody>
       </p:sp>
@@ -6279,7 +6310,7 @@
           <a:p>
             <a:pPr algn="ctr"/>
             <a:r>
-              <a:rPr b="1" sz="1200">
+              <a:rPr sz="1200" b="1">
                 <a:solidFill>
                   <a:srgbClr val="FFFFFF"/>
                 </a:solidFill>
@@ -6331,6 +6362,7 @@
           <a:lstStyle/>
           <a:p>
             <a:pPr algn="ctr"/>
+            <a:endParaRPr/>
           </a:p>
         </p:txBody>
       </p:sp>
@@ -6358,7 +6390,7 @@
           <a:p>
             <a:pPr algn="ctr"/>
             <a:r>
-              <a:rPr b="1" sz="1200">
+              <a:rPr sz="1200" b="1">
                 <a:solidFill>
                   <a:srgbClr val="FFFFFF"/>
                 </a:solidFill>
@@ -6410,6 +6442,7 @@
           <a:lstStyle/>
           <a:p>
             <a:pPr algn="ctr"/>
+            <a:endParaRPr/>
           </a:p>
         </p:txBody>
       </p:sp>
@@ -6489,6 +6522,7 @@
           <a:lstStyle/>
           <a:p>
             <a:pPr algn="ctr"/>
+            <a:endParaRPr/>
           </a:p>
         </p:txBody>
       </p:sp>
@@ -6568,6 +6602,7 @@
           <a:lstStyle/>
           <a:p>
             <a:pPr algn="ctr"/>
+            <a:endParaRPr/>
           </a:p>
         </p:txBody>
       </p:sp>
@@ -6647,6 +6682,7 @@
           <a:lstStyle/>
           <a:p>
             <a:pPr algn="ctr"/>
+            <a:endParaRPr/>
           </a:p>
         </p:txBody>
       </p:sp>
@@ -6726,6 +6762,7 @@
           <a:lstStyle/>
           <a:p>
             <a:pPr algn="ctr"/>
+            <a:endParaRPr/>
           </a:p>
         </p:txBody>
       </p:sp>
@@ -6805,6 +6842,7 @@
           <a:lstStyle/>
           <a:p>
             <a:pPr algn="ctr"/>
+            <a:endParaRPr/>
           </a:p>
         </p:txBody>
       </p:sp>
@@ -6884,6 +6922,7 @@
           <a:lstStyle/>
           <a:p>
             <a:pPr algn="ctr"/>
+            <a:endParaRPr/>
           </a:p>
         </p:txBody>
       </p:sp>
@@ -6963,6 +7002,7 @@
           <a:lstStyle/>
           <a:p>
             <a:pPr algn="ctr"/>
+            <a:endParaRPr/>
           </a:p>
         </p:txBody>
       </p:sp>
@@ -7042,6 +7082,7 @@
           <a:lstStyle/>
           <a:p>
             <a:pPr algn="ctr"/>
+            <a:endParaRPr/>
           </a:p>
         </p:txBody>
       </p:sp>
@@ -7121,6 +7162,7 @@
           <a:lstStyle/>
           <a:p>
             <a:pPr algn="ctr"/>
+            <a:endParaRPr/>
           </a:p>
         </p:txBody>
       </p:sp>
@@ -7200,6 +7242,7 @@
           <a:lstStyle/>
           <a:p>
             <a:pPr algn="ctr"/>
+            <a:endParaRPr/>
           </a:p>
         </p:txBody>
       </p:sp>
@@ -7279,6 +7322,7 @@
           <a:lstStyle/>
           <a:p>
             <a:pPr algn="ctr"/>
+            <a:endParaRPr/>
           </a:p>
         </p:txBody>
       </p:sp>
@@ -7358,6 +7402,7 @@
           <a:lstStyle/>
           <a:p>
             <a:pPr algn="ctr"/>
+            <a:endParaRPr/>
           </a:p>
         </p:txBody>
       </p:sp>
@@ -7385,7 +7430,7 @@
           <a:p>
             <a:pPr algn="l"/>
             <a:r>
-              <a:rPr b="1" sz="1500">
+              <a:rPr sz="1500" b="1">
                 <a:solidFill>
                   <a:srgbClr val="2E7D5C"/>
                 </a:solidFill>
@@ -7492,7 +7537,7 @@
 </file>
 
 <file path=ppt/slides/slide6.xml><?xml version="1.0" encoding="utf-8"?>
-<p:sld xmlns:a="http://schemas.openxmlformats.org/drawingml/2006/main" xmlns:p="http://schemas.openxmlformats.org/presentationml/2006/main" xmlns:r="http://schemas.openxmlformats.org/officeDocument/2006/relationships">
+<p:sld xmlns:a="http://schemas.openxmlformats.org/drawingml/2006/main" xmlns:r="http://schemas.openxmlformats.org/officeDocument/2006/relationships" xmlns:p="http://schemas.openxmlformats.org/presentationml/2006/main">
   <p:cSld>
     <p:bg>
       <p:bgPr>
@@ -7508,7 +7553,14 @@
         <p:cNvGrpSpPr/>
         <p:nvPr/>
       </p:nvGrpSpPr>
-      <p:grpSpPr/>
+      <p:grpSpPr>
+        <a:xfrm>
+          <a:off x="0" y="0"/>
+          <a:ext cx="0" cy="0"/>
+          <a:chOff x="0" y="0"/>
+          <a:chExt cx="0" cy="0"/>
+        </a:xfrm>
+      </p:grpSpPr>
       <p:sp>
         <p:nvSpPr>
           <p:cNvPr id="2" name="TextBox 1"/>
@@ -7621,6 +7673,7 @@
           <a:lstStyle/>
           <a:p>
             <a:pPr algn="ctr"/>
+            <a:endParaRPr/>
           </a:p>
         </p:txBody>
       </p:sp>
@@ -7736,6 +7789,7 @@
           <a:lstStyle/>
           <a:p>
             <a:pPr algn="ctr"/>
+            <a:endParaRPr/>
           </a:p>
         </p:txBody>
       </p:sp>
@@ -7851,6 +7905,7 @@
           <a:lstStyle/>
           <a:p>
             <a:pPr algn="ctr"/>
+            <a:endParaRPr/>
           </a:p>
         </p:txBody>
       </p:sp>
@@ -7966,6 +8021,7 @@
           <a:lstStyle/>
           <a:p>
             <a:pPr algn="ctr"/>
+            <a:endParaRPr/>
           </a:p>
         </p:txBody>
       </p:sp>
@@ -7978,7 +8034,7 @@
         <p:spPr>
           <a:xfrm>
             <a:off x="8046720" y="1755648"/>
-            <a:ext cx="3291840" cy="274320"/>
+            <a:ext cx="1797287" cy="323165"/>
           </a:xfrm>
           <a:prstGeom prst="rect">
             <a:avLst/>
@@ -7993,10 +8049,7 @@
           <a:p>
             <a:pPr algn="l"/>
             <a:r>
-              <a:rPr b="1" sz="1500">
-                <a:solidFill>
-                  <a:srgbClr val="FFFFFF"/>
-                </a:solidFill>
+              <a:rPr sz="1500" b="1" dirty="0">
                 <a:latin typeface="Aptos"/>
               </a:rPr>
               <a:t>Operational value</a:t>
@@ -8100,7 +8153,7 @@
 </file>
 
 <file path=ppt/slides/slide7.xml><?xml version="1.0" encoding="utf-8"?>
-<p:sld xmlns:a="http://schemas.openxmlformats.org/drawingml/2006/main" xmlns:p="http://schemas.openxmlformats.org/presentationml/2006/main" xmlns:r="http://schemas.openxmlformats.org/officeDocument/2006/relationships">
+<p:sld xmlns:a="http://schemas.openxmlformats.org/drawingml/2006/main" xmlns:r="http://schemas.openxmlformats.org/officeDocument/2006/relationships" xmlns:p="http://schemas.openxmlformats.org/presentationml/2006/main">
   <p:cSld>
     <p:bg>
       <p:bgPr>
@@ -8116,7 +8169,14 @@
         <p:cNvGrpSpPr/>
         <p:nvPr/>
       </p:nvGrpSpPr>
-      <p:grpSpPr/>
+      <p:grpSpPr>
+        <a:xfrm>
+          <a:off x="0" y="0"/>
+          <a:ext cx="0" cy="0"/>
+          <a:chOff x="0" y="0"/>
+          <a:chExt cx="0" cy="0"/>
+        </a:xfrm>
+      </p:grpSpPr>
       <p:sp>
         <p:nvSpPr>
           <p:cNvPr id="2" name="TextBox 1"/>
@@ -8126,7 +8186,7 @@
         <p:spPr>
           <a:xfrm>
             <a:off x="594360" y="411480"/>
-            <a:ext cx="8686800" cy="731520"/>
+            <a:ext cx="8686800" cy="492443"/>
           </a:xfrm>
           <a:prstGeom prst="rect">
             <a:avLst/>
@@ -8141,10 +8201,7 @@
           <a:p>
             <a:pPr algn="l"/>
             <a:r>
-              <a:rPr sz="2600" b="1">
-                <a:solidFill>
-                  <a:srgbClr val="FFFFFF"/>
-                </a:solidFill>
+              <a:rPr sz="2600" b="1" dirty="0">
                 <a:latin typeface="Aptos"/>
               </a:rPr>
               <a:t>Next steps</a:t>
@@ -8161,7 +8218,7 @@
         <p:spPr>
           <a:xfrm>
             <a:off x="621792" y="987552"/>
-            <a:ext cx="7772400" cy="457200"/>
+            <a:ext cx="3687228" cy="261610"/>
           </a:xfrm>
           <a:prstGeom prst="rect">
             <a:avLst/>
@@ -8176,10 +8233,7 @@
           <a:p>
             <a:pPr algn="l"/>
             <a:r>
-              <a:rPr sz="1100">
-                <a:solidFill>
-                  <a:srgbClr val="FFFFFF"/>
-                </a:solidFill>
+              <a:rPr sz="1100" dirty="0">
                 <a:latin typeface="Aptos"/>
               </a:rPr>
               <a:t>Maintain momentum with a stronger operational pipeline</a:t>
@@ -8229,6 +8283,7 @@
           <a:lstStyle/>
           <a:p>
             <a:pPr algn="ctr"/>
+            <a:endParaRPr/>
           </a:p>
         </p:txBody>
       </p:sp>
@@ -8256,7 +8311,7 @@
           <a:p>
             <a:pPr algn="l"/>
             <a:r>
-              <a:rPr b="1" sz="1500">
+              <a:rPr sz="1500" b="1">
                 <a:solidFill>
                   <a:srgbClr val="2E7D5C"/>
                 </a:solidFill>
@@ -8380,6 +8435,7 @@
           <a:lstStyle/>
           <a:p>
             <a:pPr algn="ctr"/>
+            <a:endParaRPr/>
           </a:p>
         </p:txBody>
       </p:sp>
@@ -8407,7 +8463,7 @@
           <a:p>
             <a:pPr algn="l"/>
             <a:r>
-              <a:rPr b="1" sz="1500">
+              <a:rPr sz="1500" b="1">
                 <a:solidFill>
                   <a:srgbClr val="215E98"/>
                 </a:solidFill>
@@ -8531,6 +8587,7 @@
           <a:lstStyle/>
           <a:p>
             <a:pPr algn="ctr"/>
+            <a:endParaRPr/>
           </a:p>
         </p:txBody>
       </p:sp>
@@ -8558,7 +8615,7 @@
           <a:p>
             <a:pPr algn="l"/>
             <a:r>
-              <a:rPr b="1" sz="1500">
+              <a:rPr sz="1500" b="1">
                 <a:solidFill>
                   <a:srgbClr val="F3A334"/>
                 </a:solidFill>

</xml_diff>